<commit_message>
benchmarks complete to 15
</commit_message>
<xml_diff>
--- a/latex/images/figure_1.pptx
+++ b/latex/images/figure_1.pptx
@@ -243,7 +243,7 @@
           <a:p>
             <a:fld id="{A8952CBE-D728-904B-9997-266F66F82F62}" type="datetimeFigureOut">
               <a:rPr lang="en-GB" smtClean="0"/>
-              <a:t>22/10/2025</a:t>
+              <a:t>24/02/2026</a:t>
             </a:fld>
             <a:endParaRPr lang="en-GB"/>
           </a:p>
@@ -413,7 +413,7 @@
           <a:p>
             <a:fld id="{A8952CBE-D728-904B-9997-266F66F82F62}" type="datetimeFigureOut">
               <a:rPr lang="en-GB" smtClean="0"/>
-              <a:t>22/10/2025</a:t>
+              <a:t>24/02/2026</a:t>
             </a:fld>
             <a:endParaRPr lang="en-GB"/>
           </a:p>
@@ -593,7 +593,7 @@
           <a:p>
             <a:fld id="{A8952CBE-D728-904B-9997-266F66F82F62}" type="datetimeFigureOut">
               <a:rPr lang="en-GB" smtClean="0"/>
-              <a:t>22/10/2025</a:t>
+              <a:t>24/02/2026</a:t>
             </a:fld>
             <a:endParaRPr lang="en-GB"/>
           </a:p>
@@ -763,7 +763,7 @@
           <a:p>
             <a:fld id="{A8952CBE-D728-904B-9997-266F66F82F62}" type="datetimeFigureOut">
               <a:rPr lang="en-GB" smtClean="0"/>
-              <a:t>22/10/2025</a:t>
+              <a:t>24/02/2026</a:t>
             </a:fld>
             <a:endParaRPr lang="en-GB"/>
           </a:p>
@@ -1009,7 +1009,7 @@
           <a:p>
             <a:fld id="{A8952CBE-D728-904B-9997-266F66F82F62}" type="datetimeFigureOut">
               <a:rPr lang="en-GB" smtClean="0"/>
-              <a:t>22/10/2025</a:t>
+              <a:t>24/02/2026</a:t>
             </a:fld>
             <a:endParaRPr lang="en-GB"/>
           </a:p>
@@ -1241,7 +1241,7 @@
           <a:p>
             <a:fld id="{A8952CBE-D728-904B-9997-266F66F82F62}" type="datetimeFigureOut">
               <a:rPr lang="en-GB" smtClean="0"/>
-              <a:t>22/10/2025</a:t>
+              <a:t>24/02/2026</a:t>
             </a:fld>
             <a:endParaRPr lang="en-GB"/>
           </a:p>
@@ -1608,7 +1608,7 @@
           <a:p>
             <a:fld id="{A8952CBE-D728-904B-9997-266F66F82F62}" type="datetimeFigureOut">
               <a:rPr lang="en-GB" smtClean="0"/>
-              <a:t>22/10/2025</a:t>
+              <a:t>24/02/2026</a:t>
             </a:fld>
             <a:endParaRPr lang="en-GB"/>
           </a:p>
@@ -1726,7 +1726,7 @@
           <a:p>
             <a:fld id="{A8952CBE-D728-904B-9997-266F66F82F62}" type="datetimeFigureOut">
               <a:rPr lang="en-GB" smtClean="0"/>
-              <a:t>22/10/2025</a:t>
+              <a:t>24/02/2026</a:t>
             </a:fld>
             <a:endParaRPr lang="en-GB"/>
           </a:p>
@@ -1821,7 +1821,7 @@
           <a:p>
             <a:fld id="{A8952CBE-D728-904B-9997-266F66F82F62}" type="datetimeFigureOut">
               <a:rPr lang="en-GB" smtClean="0"/>
-              <a:t>22/10/2025</a:t>
+              <a:t>24/02/2026</a:t>
             </a:fld>
             <a:endParaRPr lang="en-GB"/>
           </a:p>
@@ -2098,7 +2098,7 @@
           <a:p>
             <a:fld id="{A8952CBE-D728-904B-9997-266F66F82F62}" type="datetimeFigureOut">
               <a:rPr lang="en-GB" smtClean="0"/>
-              <a:t>22/10/2025</a:t>
+              <a:t>24/02/2026</a:t>
             </a:fld>
             <a:endParaRPr lang="en-GB"/>
           </a:p>
@@ -2355,7 +2355,7 @@
           <a:p>
             <a:fld id="{A8952CBE-D728-904B-9997-266F66F82F62}" type="datetimeFigureOut">
               <a:rPr lang="en-GB" smtClean="0"/>
-              <a:t>22/10/2025</a:t>
+              <a:t>24/02/2026</a:t>
             </a:fld>
             <a:endParaRPr lang="en-GB"/>
           </a:p>
@@ -2568,7 +2568,7 @@
           <a:p>
             <a:fld id="{A8952CBE-D728-904B-9997-266F66F82F62}" type="datetimeFigureOut">
               <a:rPr lang="en-GB" smtClean="0"/>
-              <a:t>22/10/2025</a:t>
+              <a:t>24/02/2026</a:t>
             </a:fld>
             <a:endParaRPr lang="en-GB"/>
           </a:p>
@@ -2975,10 +2975,10 @@
       </p:grpSpPr>
       <p:pic>
         <p:nvPicPr>
-          <p:cNvPr id="5" name="Picture 4" descr="A screenshot of a computer&#10;&#10;Description automatically generated">
+          <p:cNvPr id="3" name="Picture 2">
             <a:extLst>
               <a:ext uri="{FF2B5EF4-FFF2-40B4-BE49-F238E27FC236}">
-                <a16:creationId xmlns:a16="http://schemas.microsoft.com/office/drawing/2014/main" id="{04C66B00-0FDF-1F65-21E3-252DBDCC177B}"/>
+                <a16:creationId xmlns:a16="http://schemas.microsoft.com/office/drawing/2014/main" id="{367833C5-D42C-6795-E499-09656E4671E6}"/>
               </a:ext>
             </a:extLst>
           </p:cNvPr>
@@ -2995,8 +2995,8 @@
         </p:blipFill>
         <p:spPr>
           <a:xfrm>
-            <a:off x="553788" y="0"/>
-            <a:ext cx="4455391" cy="4906501"/>
+            <a:off x="237931" y="4906501"/>
+            <a:ext cx="10323900" cy="5161950"/>
           </a:xfrm>
           <a:prstGeom prst="rect">
             <a:avLst/>
@@ -3005,10 +3005,10 @@
       </p:pic>
       <p:pic>
         <p:nvPicPr>
-          <p:cNvPr id="7" name="Picture 6" descr="A screenshot of a computer&#10;&#10;Description automatically generated">
+          <p:cNvPr id="12" name="Picture 11" descr="A screenshot of a computer&#10;&#10;Description automatically generated">
             <a:extLst>
               <a:ext uri="{FF2B5EF4-FFF2-40B4-BE49-F238E27FC236}">
-                <a16:creationId xmlns:a16="http://schemas.microsoft.com/office/drawing/2014/main" id="{87E46AC7-5545-897C-B7DC-518D041E8B9B}"/>
+                <a16:creationId xmlns:a16="http://schemas.microsoft.com/office/drawing/2014/main" id="{6DA77D01-B627-BBE0-9E36-7A7E42314B70}"/>
               </a:ext>
             </a:extLst>
           </p:cNvPr>
@@ -3025,44 +3025,197 @@
         </p:blipFill>
         <p:spPr>
           <a:xfrm>
-            <a:off x="5790585" y="0"/>
-            <a:ext cx="4438684" cy="4906501"/>
+            <a:off x="435365" y="63268"/>
+            <a:ext cx="5110099" cy="5120936"/>
           </a:xfrm>
           <a:prstGeom prst="rect">
             <a:avLst/>
           </a:prstGeom>
         </p:spPr>
       </p:pic>
-      <p:pic>
-        <p:nvPicPr>
-          <p:cNvPr id="9" name="Picture 8">
+      <p:grpSp>
+        <p:nvGrpSpPr>
+          <p:cNvPr id="22" name="Group 21">
             <a:extLst>
               <a:ext uri="{FF2B5EF4-FFF2-40B4-BE49-F238E27FC236}">
-                <a16:creationId xmlns:a16="http://schemas.microsoft.com/office/drawing/2014/main" id="{94B52C01-69D8-BAB3-EFC4-40B8155A85F0}"/>
+                <a16:creationId xmlns:a16="http://schemas.microsoft.com/office/drawing/2014/main" id="{305CC08A-E906-DA00-BB40-E2B6013EF5D5}"/>
               </a:ext>
             </a:extLst>
           </p:cNvPr>
-          <p:cNvPicPr>
-            <a:picLocks noChangeAspect="1"/>
-          </p:cNvPicPr>
+          <p:cNvGrpSpPr/>
           <p:nvPr/>
-        </p:nvPicPr>
-        <p:blipFill>
-          <a:blip r:embed="rId4"/>
-          <a:stretch>
-            <a:fillRect/>
-          </a:stretch>
-        </p:blipFill>
-        <p:spPr>
+        </p:nvGrpSpPr>
+        <p:grpSpPr>
           <a:xfrm>
-            <a:off x="1270321" y="4906501"/>
-            <a:ext cx="8259122" cy="5161951"/>
+            <a:off x="418717" y="0"/>
+            <a:ext cx="10198542" cy="5277343"/>
+            <a:chOff x="533017" y="0"/>
+            <a:chExt cx="10198542" cy="5277343"/>
           </a:xfrm>
-          <a:prstGeom prst="rect">
-            <a:avLst/>
-          </a:prstGeom>
-        </p:spPr>
-      </p:pic>
+        </p:grpSpPr>
+        <p:grpSp>
+          <p:nvGrpSpPr>
+            <p:cNvPr id="20" name="Group 19">
+              <a:extLst>
+                <a:ext uri="{FF2B5EF4-FFF2-40B4-BE49-F238E27FC236}">
+                  <a16:creationId xmlns:a16="http://schemas.microsoft.com/office/drawing/2014/main" id="{99FBD420-88CC-0242-EB8A-23BC01FF2449}"/>
+                </a:ext>
+              </a:extLst>
+            </p:cNvPr>
+            <p:cNvGrpSpPr/>
+            <p:nvPr/>
+          </p:nvGrpSpPr>
+          <p:grpSpPr>
+            <a:xfrm>
+              <a:off x="533017" y="82518"/>
+              <a:ext cx="4997138" cy="5008255"/>
+              <a:chOff x="533017" y="82518"/>
+              <a:chExt cx="4997138" cy="5008255"/>
+            </a:xfrm>
+          </p:grpSpPr>
+          <p:grpSp>
+            <p:nvGrpSpPr>
+              <p:cNvPr id="17" name="Group 16">
+                <a:extLst>
+                  <a:ext uri="{FF2B5EF4-FFF2-40B4-BE49-F238E27FC236}">
+                    <a16:creationId xmlns:a16="http://schemas.microsoft.com/office/drawing/2014/main" id="{B237238D-3CB0-2B6B-C215-1A0B158FA34C}"/>
+                  </a:ext>
+                </a:extLst>
+              </p:cNvPr>
+              <p:cNvGrpSpPr/>
+              <p:nvPr/>
+            </p:nvGrpSpPr>
+            <p:grpSpPr>
+              <a:xfrm>
+                <a:off x="533017" y="82518"/>
+                <a:ext cx="4997138" cy="5008255"/>
+                <a:chOff x="533017" y="162235"/>
+                <a:chExt cx="4997138" cy="5008255"/>
+              </a:xfrm>
+            </p:grpSpPr>
+            <p:pic>
+              <p:nvPicPr>
+                <p:cNvPr id="14" name="Picture 13" descr="A screenshot of a computer&#10;&#10;Description automatically generated">
+                  <a:extLst>
+                    <a:ext uri="{FF2B5EF4-FFF2-40B4-BE49-F238E27FC236}">
+                      <a16:creationId xmlns:a16="http://schemas.microsoft.com/office/drawing/2014/main" id="{7FE3EF3F-E449-B207-772F-B0AB3E6B6E5A}"/>
+                    </a:ext>
+                  </a:extLst>
+                </p:cNvPr>
+                <p:cNvPicPr>
+                  <a:picLocks noChangeAspect="1"/>
+                </p:cNvPicPr>
+                <p:nvPr/>
+              </p:nvPicPr>
+              <p:blipFill>
+                <a:blip r:embed="rId4"/>
+                <a:stretch>
+                  <a:fillRect/>
+                </a:stretch>
+              </p:blipFill>
+              <p:spPr>
+                <a:xfrm>
+                  <a:off x="533017" y="162235"/>
+                  <a:ext cx="4997138" cy="5008255"/>
+                </a:xfrm>
+                <a:prstGeom prst="rect">
+                  <a:avLst/>
+                </a:prstGeom>
+              </p:spPr>
+            </p:pic>
+            <p:pic>
+              <p:nvPicPr>
+                <p:cNvPr id="16" name="Picture 15" descr="A white background with black dots&#10;&#10;Description automatically generated">
+                  <a:extLst>
+                    <a:ext uri="{FF2B5EF4-FFF2-40B4-BE49-F238E27FC236}">
+                      <a16:creationId xmlns:a16="http://schemas.microsoft.com/office/drawing/2014/main" id="{7337ACF5-DF72-1DD4-97BF-0197FC202A2F}"/>
+                    </a:ext>
+                  </a:extLst>
+                </p:cNvPr>
+                <p:cNvPicPr>
+                  <a:picLocks noChangeAspect="1"/>
+                </p:cNvPicPr>
+                <p:nvPr/>
+              </p:nvPicPr>
+              <p:blipFill>
+                <a:blip r:embed="rId5"/>
+                <a:stretch>
+                  <a:fillRect/>
+                </a:stretch>
+              </p:blipFill>
+              <p:spPr>
+                <a:xfrm>
+                  <a:off x="3593354" y="1193590"/>
+                  <a:ext cx="446245" cy="453682"/>
+                </a:xfrm>
+                <a:prstGeom prst="rect">
+                  <a:avLst/>
+                </a:prstGeom>
+              </p:spPr>
+            </p:pic>
+          </p:grpSp>
+          <p:pic>
+            <p:nvPicPr>
+              <p:cNvPr id="19" name="Picture 18">
+                <a:extLst>
+                  <a:ext uri="{FF2B5EF4-FFF2-40B4-BE49-F238E27FC236}">
+                    <a16:creationId xmlns:a16="http://schemas.microsoft.com/office/drawing/2014/main" id="{879D7CD6-2ECF-1C8C-2A57-8DE0E3BD5EEB}"/>
+                  </a:ext>
+                </a:extLst>
+              </p:cNvPr>
+              <p:cNvPicPr>
+                <a:picLocks noChangeAspect="1"/>
+              </p:cNvPicPr>
+              <p:nvPr/>
+            </p:nvPicPr>
+            <p:blipFill>
+              <a:blip r:embed="rId6"/>
+              <a:stretch>
+                <a:fillRect/>
+              </a:stretch>
+            </p:blipFill>
+            <p:spPr>
+              <a:xfrm>
+                <a:off x="1180208" y="250209"/>
+                <a:ext cx="4010491" cy="191069"/>
+              </a:xfrm>
+              <a:prstGeom prst="rect">
+                <a:avLst/>
+              </a:prstGeom>
+            </p:spPr>
+          </p:pic>
+        </p:grpSp>
+        <p:pic>
+          <p:nvPicPr>
+            <p:cNvPr id="21" name="Picture 20" descr="A screenshot of a computer&#10;&#10;Description automatically generated">
+              <a:extLst>
+                <a:ext uri="{FF2B5EF4-FFF2-40B4-BE49-F238E27FC236}">
+                  <a16:creationId xmlns:a16="http://schemas.microsoft.com/office/drawing/2014/main" id="{8A7A3D44-85B7-5111-8544-E2978838F3A3}"/>
+                </a:ext>
+              </a:extLst>
+            </p:cNvPr>
+            <p:cNvPicPr>
+              <a:picLocks noChangeAspect="1"/>
+            </p:cNvPicPr>
+            <p:nvPr/>
+          </p:nvPicPr>
+          <p:blipFill>
+            <a:blip r:embed="rId3"/>
+            <a:stretch>
+              <a:fillRect/>
+            </a:stretch>
+          </p:blipFill>
+          <p:spPr>
+            <a:xfrm>
+              <a:off x="5465384" y="0"/>
+              <a:ext cx="5266175" cy="5277343"/>
+            </a:xfrm>
+            <a:prstGeom prst="rect">
+              <a:avLst/>
+            </a:prstGeom>
+          </p:spPr>
+        </p:pic>
+      </p:grpSp>
     </p:spTree>
     <p:extLst>
       <p:ext uri="{BB962C8B-B14F-4D97-AF65-F5344CB8AC3E}">

</xml_diff>